<commit_message>
docs(deck): reframe the ask — drop Paab, swap "partner" for contacts + continued rails access
Slides 19–25 (+ consistency on 9, 18):
- Remove all Paab references (slide 22 product list, slide 9 roadmap row).
- Slide 24 ask reframed from "formalize partnership / unblock Paab" to two
  asks: access to Paynow's growing contacts as the GTM channel for selling
  the settlement engine, plus continued access to the rails + core
  infrastructure already built on.
- Slide 18 partnership pull-quote softened to match (channel, not
  "vertical solution").

Co-Authored-By: Claude Opus 4.8 (1M context) <noreply@anthropic.com>
</commit_message>
<xml_diff>
--- a/deliverables/internship-return/zimlivestock-final-presentation.pptx
+++ b/deliverables/internship-return/zimlivestock-final-presentation.pptx
@@ -11010,7 +11010,7 @@
                 <a:ea typeface="Calibri" pitchFamily="34" charset="-122"/>
                 <a:cs typeface="Calibri" pitchFamily="34" charset="-120"/>
               </a:rPr>
-              <a:t>8 → 12 houses live. Case studies compound. Paynow formalizes us as its livestock vertical solution.</a:t>
+              <a:t>8 → 12 houses live. Case studies compound. Paynow's contacts become the channel that sources new houses.</a:t>
             </a:r>
             <a:endParaRPr lang="en-US" sz="1150" dirty="0"/>
           </a:p>
@@ -11180,7 +11180,7 @@
                 <a:ea typeface="Georgia" pitchFamily="34" charset="-122"/>
                 <a:cs typeface="Georgia" pitchFamily="34" charset="-120"/>
               </a:rPr>
-              <a:t>Position ZimLivestock as Paynow's vertical solution for livestock — reciprocal: we grow their GMV, they grow our pipeline.</a:t>
+              <a:t>Paynow's growing contacts are the channel for selling this engine — and every house it sources routes its GMV onto Paynow's rails.</a:t>
             </a:r>
             <a:pPr indent="0" marL="0">
               <a:buNone/>
@@ -15903,21 +15903,7 @@
                 <a:ea typeface="Calibri" pitchFamily="34" charset="-122"/>
                 <a:cs typeface="Calibri" pitchFamily="34" charset="-120"/>
               </a:rPr>
-              <a:t>Core Express Checkout  ·  Bisafe escrow  ·  BillPay-as-biller  ·  EcoCash USSD  ·  merchant transfers  ·  </a:t>
-            </a:r>
-            <a:pPr indent="0" marL="0">
-              <a:buNone/>
-            </a:pPr>
-            <a:r>
-              <a:rPr lang="en-US" sz="1150" i="1" dirty="0">
-                <a:solidFill>
-                  <a:srgbClr val="7A4F47"/>
-                </a:solidFill>
-                <a:latin typeface="Calibri" pitchFamily="34" charset="0"/>
-                <a:ea typeface="Calibri" pitchFamily="34" charset="-122"/>
-                <a:cs typeface="Calibri" pitchFamily="34" charset="-120"/>
-              </a:rPr>
-              <a:t>Paab cash (once unblocked)</a:t>
+              <a:t>Core Express Checkout  ·  Bisafe escrow  ·  BillPay-as-biller  ·  EcoCash USSD  ·  merchant transfers  ·  SMS notifications</a:t>
             </a:r>
             <a:endParaRPr lang="en-US" sz="1150" dirty="0"/>
           </a:p>
@@ -17067,7 +17053,7 @@
                 <a:ea typeface="Georgia" pitchFamily="34" charset="-122"/>
                 <a:cs typeface="Georgia" pitchFamily="34" charset="-120"/>
               </a:rPr>
-              <a:t>Three things, none of them a cheque.</a:t>
+              <a:t>Two things, neither of them a cheque.</a:t>
             </a:r>
             <a:endParaRPr lang="en-US" sz="1900" dirty="0"/>
           </a:p>
@@ -17081,7 +17067,7 @@
         </p:nvSpPr>
         <p:spPr>
           <a:xfrm>
-            <a:off x="640080" y="2423160"/>
+            <a:off x="640080" y="2514600"/>
             <a:ext cx="457200" cy="640080"/>
           </a:xfrm>
           <a:prstGeom prst="rect">
@@ -17120,8 +17106,8 @@
         </p:nvSpPr>
         <p:spPr>
           <a:xfrm>
-            <a:off x="1188720" y="2441448"/>
-            <a:ext cx="7315200" cy="713232"/>
+            <a:off x="1188720" y="2532888"/>
+            <a:ext cx="7315200" cy="1005840"/>
           </a:xfrm>
           <a:prstGeom prst="rect">
             <a:avLst/>
@@ -17137,7 +17123,7 @@
               <a:buNone/>
             </a:pPr>
             <a:r>
-              <a:rPr lang="en-US" sz="1600" b="1" dirty="0">
+              <a:rPr lang="en-US" sz="1700" b="1" dirty="0">
                 <a:solidFill>
                   <a:srgbClr val="F5E6D3"/>
                 </a:solidFill>
@@ -17145,13 +17131,16 @@
                 <a:ea typeface="Calibri" pitchFamily="34" charset="-122"/>
                 <a:cs typeface="Calibri" pitchFamily="34" charset="-120"/>
               </a:rPr>
-              <a:t>Unblock the rails   </a:t>
-            </a:r>
-            <a:pPr indent="0" marL="0">
-              <a:buNone/>
-            </a:pPr>
-            <a:r>
-              <a:rPr lang="en-US" sz="1200" dirty="0">
+              <a:t>Access to your growing contacts   </a:t>
+            </a:r>
+            <a:endParaRPr lang="en-US" sz="1700" dirty="0"/>
+          </a:p>
+          <a:p>
+            <a:pPr indent="0" marL="0">
+              <a:buNone/>
+            </a:pPr>
+            <a:r>
+              <a:rPr lang="en-US" sz="1250" dirty="0">
                 <a:solidFill>
                   <a:srgbClr val="BFAA98"/>
                 </a:solidFill>
@@ -17159,9 +17148,9 @@
                 <a:ea typeface="Calibri" pitchFamily="34" charset="-122"/>
                 <a:cs typeface="Calibri" pitchFamily="34" charset="-120"/>
               </a:rPr>
-              <a:t>Paab sandbox + docs (the only red on the board) and the BillPay PAY round-trip (vendor-portal creds; AUTH is already live). Both widen the buyer base and lift adoption.</a:t>
-            </a:r>
-            <a:endParaRPr lang="en-US" sz="1600" dirty="0"/>
+              <a:t>Paynow's expanding network of merchants, billers and industry relationships — as the starting point for selling this settlement engine into the livestock market. Your contacts are the doors; I do the on-the-ground operating you don't want to.</a:t>
+            </a:r>
+            <a:endParaRPr lang="en-US" sz="1700" dirty="0"/>
           </a:p>
         </p:txBody>
       </p:sp>
@@ -17173,7 +17162,7 @@
         </p:nvSpPr>
         <p:spPr>
           <a:xfrm>
-            <a:off x="640080" y="3172968"/>
+            <a:off x="640080" y="3611880"/>
             <a:ext cx="457200" cy="640080"/>
           </a:xfrm>
           <a:prstGeom prst="rect">
@@ -17212,8 +17201,8 @@
         </p:nvSpPr>
         <p:spPr>
           <a:xfrm>
-            <a:off x="1188720" y="3191256"/>
-            <a:ext cx="7315200" cy="713232"/>
+            <a:off x="1188720" y="3630168"/>
+            <a:ext cx="7315200" cy="1005840"/>
           </a:xfrm>
           <a:prstGeom prst="rect">
             <a:avLst/>
@@ -17229,7 +17218,7 @@
               <a:buNone/>
             </a:pPr>
             <a:r>
-              <a:rPr lang="en-US" sz="1600" b="1" dirty="0">
+              <a:rPr lang="en-US" sz="1700" b="1" dirty="0">
                 <a:solidFill>
                   <a:srgbClr val="F5E6D3"/>
                 </a:solidFill>
@@ -17237,13 +17226,16 @@
                 <a:ea typeface="Calibri" pitchFamily="34" charset="-122"/>
                 <a:cs typeface="Calibri" pitchFamily="34" charset="-120"/>
               </a:rPr>
-              <a:t>Formalize the partnership   </a:t>
-            </a:r>
-            <a:pPr indent="0" marL="0">
-              <a:buNone/>
-            </a:pPr>
-            <a:r>
-              <a:rPr lang="en-US" sz="1200" dirty="0">
+              <a:t>Continued access to the rails &amp; core infrastructure   </a:t>
+            </a:r>
+            <a:endParaRPr lang="en-US" sz="1700" dirty="0"/>
+          </a:p>
+          <a:p>
+            <a:pPr indent="0" marL="0">
+              <a:buNone/>
+            </a:pPr>
+            <a:r>
+              <a:rPr lang="en-US" sz="1250" dirty="0">
                 <a:solidFill>
                   <a:srgbClr val="BFAA98"/>
                 </a:solidFill>
@@ -17251,107 +17243,15 @@
                 <a:ea typeface="Calibri" pitchFamily="34" charset="-122"/>
                 <a:cs typeface="Calibri" pitchFamily="34" charset="-120"/>
               </a:rPr>
-              <a:t>Name ZimLivestock as Paynow's livestock vertical solution; Paynow BD refers livestock-industry prospects. We grow your GMV; you grow our pipeline.</a:t>
-            </a:r>
-            <a:endParaRPr lang="en-US" sz="1600" dirty="0"/>
+              <a:t>Keep me on the Paynow stack I've built ZimLivestock on — Core Express Checkout, BillPay-as-biller, EcoCash USSD, merchant transfers, SMS. The engine runs on your rails; staying plugged in is what keeps every dollar of GMV flowing onto them.</a:t>
+            </a:r>
+            <a:endParaRPr lang="en-US" sz="1700" dirty="0"/>
           </a:p>
         </p:txBody>
       </p:sp>
       <p:sp>
         <p:nvSpPr>
           <p:cNvPr id="10" name="Text 8"/>
-          <p:cNvSpPr/>
-          <p:nvPr/>
-        </p:nvSpPr>
-        <p:spPr>
-          <a:xfrm>
-            <a:off x="640080" y="3922776"/>
-            <a:ext cx="457200" cy="640080"/>
-          </a:xfrm>
-          <a:prstGeom prst="rect">
-            <a:avLst/>
-          </a:prstGeom>
-          <a:noFill/>
-          <a:ln/>
-        </p:spPr>
-        <p:txBody>
-          <a:bodyPr wrap="square" lIns="0" tIns="0" rIns="0" bIns="0" rtlCol="0" anchor="ctr"/>
-          <a:lstStyle/>
-          <a:p>
-            <a:pPr indent="0" marL="0">
-              <a:buNone/>
-            </a:pPr>
-            <a:r>
-              <a:rPr lang="en-US" sz="3000" b="1" dirty="0">
-                <a:solidFill>
-                  <a:srgbClr val="D4A843"/>
-                </a:solidFill>
-                <a:latin typeface="Georgia" pitchFamily="34" charset="0"/>
-                <a:ea typeface="Georgia" pitchFamily="34" charset="-122"/>
-                <a:cs typeface="Georgia" pitchFamily="34" charset="-120"/>
-              </a:rPr>
-              <a:t>3</a:t>
-            </a:r>
-            <a:endParaRPr lang="en-US" sz="3000" dirty="0"/>
-          </a:p>
-        </p:txBody>
-      </p:sp>
-      <p:sp>
-        <p:nvSpPr>
-          <p:cNvPr id="11" name="Text 9"/>
-          <p:cNvSpPr/>
-          <p:nvPr/>
-        </p:nvSpPr>
-        <p:spPr>
-          <a:xfrm>
-            <a:off x="1188720" y="3941064"/>
-            <a:ext cx="7315200" cy="713232"/>
-          </a:xfrm>
-          <a:prstGeom prst="rect">
-            <a:avLst/>
-          </a:prstGeom>
-          <a:noFill/>
-          <a:ln/>
-        </p:spPr>
-        <p:txBody>
-          <a:bodyPr wrap="square" lIns="0" tIns="0" rIns="0" bIns="0" rtlCol="0" anchor="t"/>
-          <a:lstStyle/>
-          <a:p>
-            <a:pPr indent="0" marL="0">
-              <a:buNone/>
-            </a:pPr>
-            <a:r>
-              <a:rPr lang="en-US" sz="1600" b="1" dirty="0">
-                <a:solidFill>
-                  <a:srgbClr val="F5E6D3"/>
-                </a:solidFill>
-                <a:latin typeface="Calibri" pitchFamily="34" charset="0"/>
-                <a:ea typeface="Calibri" pitchFamily="34" charset="-122"/>
-                <a:cs typeface="Calibri" pitchFamily="34" charset="-120"/>
-              </a:rPr>
-              <a:t>Open one door   </a:t>
-            </a:r>
-            <a:pPr indent="0" marL="0">
-              <a:buNone/>
-            </a:pPr>
-            <a:r>
-              <a:rPr lang="en-US" sz="1200" dirty="0">
-                <a:solidFill>
-                  <a:srgbClr val="BFAA98"/>
-                </a:solidFill>
-                <a:latin typeface="Calibri" pitchFamily="34" charset="0"/>
-                <a:ea typeface="Calibri" pitchFamily="34" charset="-122"/>
-                <a:cs typeface="Calibri" pitchFamily="34" charset="-120"/>
-              </a:rPr>
-              <a:t>A warm intro to one Harare-area auction house. The pilot is paid by the customer, not by Paynow — I just need the room.</a:t>
-            </a:r>
-            <a:endParaRPr lang="en-US" sz="1600" dirty="0"/>
-          </a:p>
-        </p:txBody>
-      </p:sp>
-      <p:sp>
-        <p:nvSpPr>
-          <p:cNvPr id="12" name="Text 10"/>
           <p:cNvSpPr/>
           <p:nvPr/>
         </p:nvSpPr>
@@ -17390,7 +17290,7 @@
       </p:sp>
       <p:sp>
         <p:nvSpPr>
-          <p:cNvPr id="13" name="Text 11"/>
+          <p:cNvPr id="11" name="Text 9"/>
           <p:cNvSpPr/>
           <p:nvPr/>
         </p:nvSpPr>
@@ -22293,88 +22193,7 @@
       </p:sp>
       <p:sp>
         <p:nvSpPr>
-          <p:cNvPr id="26" name="Shape 24"/>
-          <p:cNvSpPr/>
-          <p:nvPr/>
-        </p:nvSpPr>
-        <p:spPr>
-          <a:xfrm>
-            <a:off x="4754880" y="3977640"/>
-            <a:ext cx="219456" cy="219456"/>
-          </a:xfrm>
-          <a:prstGeom prst="ellipse">
-            <a:avLst/>
-          </a:prstGeom>
-          <a:solidFill>
-            <a:srgbClr val="FFFFFF"/>
-          </a:solidFill>
-          <a:ln w="19050">
-            <a:solidFill>
-              <a:srgbClr val="7A4F47"/>
-            </a:solidFill>
-            <a:prstDash val="solid"/>
-          </a:ln>
-        </p:spPr>
-      </p:sp>
-      <p:sp>
-        <p:nvSpPr>
-          <p:cNvPr id="27" name="Text 25"/>
-          <p:cNvSpPr/>
-          <p:nvPr/>
-        </p:nvSpPr>
-        <p:spPr>
-          <a:xfrm>
-            <a:off x="5120640" y="3941064"/>
-            <a:ext cx="3611880" cy="548640"/>
-          </a:xfrm>
-          <a:prstGeom prst="rect">
-            <a:avLst/>
-          </a:prstGeom>
-          <a:noFill/>
-          <a:ln/>
-        </p:spPr>
-        <p:txBody>
-          <a:bodyPr wrap="square" lIns="0" tIns="0" rIns="0" bIns="0" rtlCol="0" anchor="ctr"/>
-          <a:lstStyle/>
-          <a:p>
-            <a:pPr indent="0" marL="0">
-              <a:buNone/>
-            </a:pPr>
-            <a:r>
-              <a:rPr lang="en-US" sz="1250" b="1" dirty="0">
-                <a:solidFill>
-                  <a:srgbClr val="2D1B1A"/>
-                </a:solidFill>
-                <a:latin typeface="Calibri" pitchFamily="34" charset="0"/>
-                <a:ea typeface="Calibri" pitchFamily="34" charset="-122"/>
-                <a:cs typeface="Calibri" pitchFamily="34" charset="-120"/>
-              </a:rPr>
-              <a:t>Paab cash-collection</a:t>
-            </a:r>
-            <a:endParaRPr lang="en-US" sz="1250" dirty="0"/>
-          </a:p>
-          <a:p>
-            <a:pPr indent="0" marL="0">
-              <a:buNone/>
-            </a:pPr>
-            <a:r>
-              <a:rPr lang="en-US" sz="1000" i="1" dirty="0">
-                <a:solidFill>
-                  <a:srgbClr val="7A4F47"/>
-                </a:solidFill>
-                <a:latin typeface="Calibri" pitchFamily="34" charset="0"/>
-                <a:ea typeface="Calibri" pitchFamily="34" charset="-122"/>
-                <a:cs typeface="Calibri" pitchFamily="34" charset="-120"/>
-              </a:rPr>
-              <a:t>designed, awaiting Paynow Paab spec</a:t>
-            </a:r>
-            <a:endParaRPr lang="en-US" sz="1250" dirty="0"/>
-          </a:p>
-        </p:txBody>
-      </p:sp>
-      <p:sp>
-        <p:nvSpPr>
-          <p:cNvPr id="28" name="Text 26"/>
+          <p:cNvPr id="26" name="Text 24"/>
           <p:cNvSpPr/>
           <p:nvPr/>
         </p:nvSpPr>
@@ -22413,7 +22232,7 @@
       </p:sp>
       <p:sp>
         <p:nvSpPr>
-          <p:cNvPr id="29" name="Text 27"/>
+          <p:cNvPr id="27" name="Text 25"/>
           <p:cNvSpPr/>
           <p:nvPr/>
         </p:nvSpPr>

</xml_diff>